<commit_message>
Add 28nm ASIC throughput point (~800 MHz -> up to ~200 FPS)
- Same-node FPGA->ASIC win (Kintex-7 is 28nm; logic-only 0-DSP datapath, ~3-4x)
- Two operating points at constant ~255 FPS/W: ~800MHz/200FPS/0.8W (perf)
  vs 200MHz/51FPS/0.2W (low-power); cost math unchanged (low-power point)
- Updated README, COST_COMPARISON, DEVPOST, hardware spec (Fmax + perf model)
- Rebuilt pitch deck (title chip, results FPS card, cost strip)
- Composited styled ASIC banner into demo video hardware scene (60-72s);
  timeline preserved at exactly 180.000s, narration untouched
</commit_message>
<xml_diff>
--- a/docs/SiliconYOLO_pitch.pptx
+++ b/docs/SiliconYOLO_pitch.pptx
@@ -2711,7 +2711,7 @@
         <p:spPr>
           <a:xfrm>
             <a:off x="658368" y="5029200"/>
-            <a:ext cx="1248156" cy="502920"/>
+            <a:ext cx="2112264" cy="502920"/>
           </a:xfrm>
           <a:prstGeom prst="roundRect">
             <a:avLst>
@@ -2738,7 +2738,7 @@
         <p:spPr>
           <a:xfrm>
             <a:off x="658368" y="5029200"/>
-            <a:ext cx="1248156" cy="502920"/>
+            <a:ext cx="2112264" cy="502920"/>
           </a:xfrm>
           <a:prstGeom prst="rect">
             <a:avLst/>
@@ -2762,7 +2762,7 @@
                 <a:ea typeface="Consolas" pitchFamily="34" charset="-122"/>
                 <a:cs typeface="Consolas" pitchFamily="34" charset="-120"/>
               </a:rPr>
-              <a:t>~51 FPS</a:t>
+              <a:t>~51 FPS (FPGA)</a:t>
             </a:r>
             <a:endParaRPr lang="en-US" sz="1400" dirty="0"/>
           </a:p>
@@ -2776,8 +2776,8 @@
         </p:nvSpPr>
         <p:spPr>
           <a:xfrm>
-            <a:off x="2135124" y="5029200"/>
-            <a:ext cx="1001268" cy="502920"/>
+            <a:off x="2999232" y="5029200"/>
+            <a:ext cx="2976372" cy="502920"/>
           </a:xfrm>
           <a:prstGeom prst="roundRect">
             <a:avLst>
@@ -2803,8 +2803,8 @@
         </p:nvSpPr>
         <p:spPr>
           <a:xfrm>
-            <a:off x="2135124" y="5029200"/>
-            <a:ext cx="1001268" cy="502920"/>
+            <a:off x="2999232" y="5029200"/>
+            <a:ext cx="2976372" cy="502920"/>
           </a:xfrm>
           <a:prstGeom prst="rect">
             <a:avLst/>
@@ -2828,7 +2828,7 @@
                 <a:ea typeface="Consolas" pitchFamily="34" charset="-122"/>
                 <a:cs typeface="Consolas" pitchFamily="34" charset="-120"/>
               </a:rPr>
-              <a:t>0 DSP</a:t>
+              <a:t>up to ~200 FPS (ASIC)</a:t>
             </a:r>
             <a:endParaRPr lang="en-US" sz="1400" dirty="0"/>
           </a:p>
@@ -2842,8 +2842,8 @@
         </p:nvSpPr>
         <p:spPr>
           <a:xfrm>
-            <a:off x="3364992" y="5029200"/>
-            <a:ext cx="1124712" cy="502920"/>
+            <a:off x="6204204" y="5029200"/>
+            <a:ext cx="1001268" cy="502920"/>
           </a:xfrm>
           <a:prstGeom prst="roundRect">
             <a:avLst>
@@ -2869,8 +2869,8 @@
         </p:nvSpPr>
         <p:spPr>
           <a:xfrm>
-            <a:off x="3364992" y="5029200"/>
-            <a:ext cx="1124712" cy="502920"/>
+            <a:off x="6204204" y="5029200"/>
+            <a:ext cx="1001268" cy="502920"/>
           </a:xfrm>
           <a:prstGeom prst="rect">
             <a:avLst/>
@@ -2894,7 +2894,7 @@
                 <a:ea typeface="Consolas" pitchFamily="34" charset="-122"/>
                 <a:cs typeface="Consolas" pitchFamily="34" charset="-120"/>
               </a:rPr>
-              <a:t>~3.2 W</a:t>
+              <a:t>0 DSP</a:t>
             </a:r>
             <a:endParaRPr lang="en-US" sz="1400" dirty="0"/>
           </a:p>
@@ -2908,8 +2908,8 @@
         </p:nvSpPr>
         <p:spPr>
           <a:xfrm>
-            <a:off x="4718304" y="5029200"/>
-            <a:ext cx="2359152" cy="502920"/>
+            <a:off x="7434072" y="5029200"/>
+            <a:ext cx="1124712" cy="502920"/>
           </a:xfrm>
           <a:prstGeom prst="roundRect">
             <a:avLst>
@@ -2935,8 +2935,8 @@
         </p:nvSpPr>
         <p:spPr>
           <a:xfrm>
-            <a:off x="4718304" y="5029200"/>
-            <a:ext cx="2359152" cy="502920"/>
+            <a:off x="7434072" y="5029200"/>
+            <a:ext cx="1124712" cy="502920"/>
           </a:xfrm>
           <a:prstGeom prst="rect">
             <a:avLst/>
@@ -2960,7 +2960,7 @@
                 <a:ea typeface="Consolas" pitchFamily="34" charset="-122"/>
                 <a:cs typeface="Consolas" pitchFamily="34" charset="-120"/>
               </a:rPr>
-              <a:t>INT8 · bit-exact</a:t>
+              <a:t>~3.2 W</a:t>
             </a:r>
             <a:endParaRPr lang="en-US" sz="1400" dirty="0"/>
           </a:p>
@@ -2968,7 +2968,73 @@
       </p:sp>
       <p:sp>
         <p:nvSpPr>
-          <p:cNvPr id="48" name="Text 46"/>
+          <p:cNvPr id="48" name="Shape 46"/>
+          <p:cNvSpPr/>
+          <p:nvPr/>
+        </p:nvSpPr>
+        <p:spPr>
+          <a:xfrm>
+            <a:off x="8787384" y="5029200"/>
+            <a:ext cx="877824" cy="502920"/>
+          </a:xfrm>
+          <a:prstGeom prst="roundRect">
+            <a:avLst>
+              <a:gd name="adj" fmla="val 49091"/>
+            </a:avLst>
+          </a:prstGeom>
+          <a:solidFill>
+            <a:srgbClr val="13203A"/>
+          </a:solidFill>
+          <a:ln w="15875">
+            <a:solidFill>
+              <a:srgbClr val="4F8BFF"/>
+            </a:solidFill>
+            <a:prstDash val="solid"/>
+          </a:ln>
+        </p:spPr>
+      </p:sp>
+      <p:sp>
+        <p:nvSpPr>
+          <p:cNvPr id="49" name="Text 47"/>
+          <p:cNvSpPr/>
+          <p:nvPr/>
+        </p:nvSpPr>
+        <p:spPr>
+          <a:xfrm>
+            <a:off x="8787384" y="5029200"/>
+            <a:ext cx="877824" cy="502920"/>
+          </a:xfrm>
+          <a:prstGeom prst="rect">
+            <a:avLst/>
+          </a:prstGeom>
+          <a:noFill/>
+          <a:ln/>
+        </p:spPr>
+        <p:txBody>
+          <a:bodyPr wrap="square" rtlCol="0" anchor="ctr"/>
+          <a:lstStyle/>
+          <a:p>
+            <a:pPr algn="ctr" indent="0" marL="0">
+              <a:buNone/>
+            </a:pPr>
+            <a:r>
+              <a:rPr lang="en-US" sz="1400" b="1" dirty="0">
+                <a:solidFill>
+                  <a:srgbClr val="7FB2FF"/>
+                </a:solidFill>
+                <a:latin typeface="Consolas" pitchFamily="34" charset="0"/>
+                <a:ea typeface="Consolas" pitchFamily="34" charset="-122"/>
+                <a:cs typeface="Consolas" pitchFamily="34" charset="-120"/>
+              </a:rPr>
+              <a:t>INT8</a:t>
+            </a:r>
+            <a:endParaRPr lang="en-US" sz="1400" dirty="0"/>
+          </a:p>
+        </p:txBody>
+      </p:sp>
+      <p:sp>
+        <p:nvSpPr>
+          <p:cNvPr id="50" name="Text 48"/>
           <p:cNvSpPr/>
           <p:nvPr/>
         </p:nvSpPr>
@@ -13067,7 +13133,7 @@
                 <a:ea typeface="Calibri" pitchFamily="34" charset="-122"/>
                 <a:cs typeface="Calibri" pitchFamily="34" charset="-120"/>
               </a:rPr>
-              <a:t>Kintex-7 XC7K325T</a:t>
+              <a:t>Kintex-7 · ~200 FPS as 28 nm ASIC</a:t>
             </a:r>
             <a:endParaRPr lang="en-US" sz="1100" dirty="0"/>
           </a:p>
@@ -15506,7 +15572,7 @@
         <p:spPr>
           <a:xfrm>
             <a:off x="868680" y="4526280"/>
-            <a:ext cx="4846320" cy="1280160"/>
+            <a:ext cx="4846320" cy="1325880"/>
           </a:xfrm>
           <a:prstGeom prst="rect">
             <a:avLst/>
@@ -15520,12 +15586,12 @@
           <a:p>
             <a:pPr indent="0" marL="0">
               <a:lnSpc>
-                <a:spcPct val="120000"/>
+                <a:spcPct val="115000"/>
               </a:lnSpc>
               <a:buNone/>
             </a:pPr>
             <a:r>
-              <a:rPr lang="en-US" sz="1500" b="1" dirty="0">
+              <a:rPr lang="en-US" sz="1400" b="1" dirty="0">
                 <a:solidFill>
                   <a:srgbClr val="7FB2FF"/>
                 </a:solidFill>
@@ -15537,12 +15603,12 @@
             </a:r>
             <a:pPr indent="0" marL="0">
               <a:lnSpc>
-                <a:spcPct val="120000"/>
+                <a:spcPct val="115000"/>
               </a:lnSpc>
               <a:buNone/>
             </a:pPr>
             <a:r>
-              <a:rPr lang="en-US" sz="1500" dirty="0">
+              <a:rPr lang="en-US" sz="1400" dirty="0">
                 <a:solidFill>
                   <a:srgbClr val="9FB0D0"/>
                 </a:solidFill>
@@ -15554,12 +15620,12 @@
             </a:r>
             <a:pPr indent="0" marL="0">
               <a:lnSpc>
-                <a:spcPct val="120000"/>
+                <a:spcPct val="115000"/>
               </a:lnSpc>
               <a:buNone/>
             </a:pPr>
             <a:r>
-              <a:rPr lang="en-US" sz="1500" b="1" dirty="0">
+              <a:rPr lang="en-US" sz="1400" b="1" dirty="0">
                 <a:solidFill>
                   <a:srgbClr val="53D08A"/>
                 </a:solidFill>
@@ -15572,12 +15638,12 @@
             </a:r>
             <a:pPr indent="0" marL="0">
               <a:lnSpc>
-                <a:spcPct val="120000"/>
+                <a:spcPct val="115000"/>
               </a:lnSpc>
               <a:buNone/>
             </a:pPr>
             <a:r>
-              <a:rPr lang="en-US" sz="1500" b="1" dirty="0">
+              <a:rPr lang="en-US" sz="1400" b="1" dirty="0">
                 <a:solidFill>
                   <a:srgbClr val="F5B544"/>
                 </a:solidFill>
@@ -15589,12 +15655,12 @@
             </a:r>
             <a:pPr indent="0" marL="0">
               <a:lnSpc>
-                <a:spcPct val="120000"/>
+                <a:spcPct val="115000"/>
               </a:lnSpc>
               <a:buNone/>
             </a:pPr>
             <a:r>
-              <a:rPr lang="en-US" sz="1500" dirty="0">
+              <a:rPr lang="en-US" sz="1400" dirty="0">
                 <a:solidFill>
                   <a:srgbClr val="9FB0D0"/>
                 </a:solidFill>
@@ -15606,12 +15672,12 @@
             </a:r>
             <a:pPr indent="0" marL="0">
               <a:lnSpc>
-                <a:spcPct val="120000"/>
+                <a:spcPct val="115000"/>
               </a:lnSpc>
               <a:buNone/>
             </a:pPr>
             <a:r>
-              <a:rPr lang="en-US" sz="1500" b="1" dirty="0">
+              <a:rPr lang="en-US" sz="1400" b="1" dirty="0">
                 <a:solidFill>
                   <a:srgbClr val="EAF0FF"/>
                 </a:solidFill>
@@ -15623,12 +15689,12 @@
             </a:r>
             <a:pPr indent="0" marL="0">
               <a:lnSpc>
-                <a:spcPct val="120000"/>
+                <a:spcPct val="115000"/>
               </a:lnSpc>
               <a:buNone/>
             </a:pPr>
             <a:r>
-              <a:rPr lang="en-US" sz="1500" dirty="0">
+              <a:rPr lang="en-US" sz="1400" dirty="0">
                 <a:solidFill>
                   <a:srgbClr val="9FB0D0"/>
                 </a:solidFill>
@@ -15638,7 +15704,70 @@
               </a:rPr>
               <a:t>  — every frame, no jitter</a:t>
             </a:r>
-            <a:endParaRPr lang="en-US" sz="1500" dirty="0"/>
+            <a:pPr indent="0" marL="0">
+              <a:lnSpc>
+                <a:spcPct val="115000"/>
+              </a:lnSpc>
+              <a:buNone/>
+            </a:pPr>
+            <a:endParaRPr lang="en-US" sz="1400" dirty="0"/>
+          </a:p>
+          <a:p>
+            <a:pPr indent="0" marL="0">
+              <a:lnSpc>
+                <a:spcPct val="115000"/>
+              </a:lnSpc>
+              <a:buNone/>
+            </a:pPr>
+            <a:r>
+              <a:rPr lang="en-US" sz="1400" dirty="0">
+                <a:solidFill>
+                  <a:srgbClr val="9FB0D0"/>
+                </a:solidFill>
+                <a:latin typeface="Calibri" pitchFamily="34" charset="0"/>
+                <a:ea typeface="Calibri" pitchFamily="34" charset="-122"/>
+                <a:cs typeface="Calibri" pitchFamily="34" charset="-120"/>
+              </a:rPr>
+              <a:t>Same netlist scales to </a:t>
+            </a:r>
+            <a:endParaRPr lang="en-US" sz="1400" dirty="0"/>
+          </a:p>
+          <a:p>
+            <a:pPr indent="0" marL="0">
+              <a:lnSpc>
+                <a:spcPct val="115000"/>
+              </a:lnSpc>
+              <a:buNone/>
+            </a:pPr>
+            <a:r>
+              <a:rPr lang="en-US" sz="1400" b="1" dirty="0">
+                <a:solidFill>
+                  <a:srgbClr val="7FB2FF"/>
+                </a:solidFill>
+                <a:latin typeface="Calibri" pitchFamily="34" charset="0"/>
+                <a:ea typeface="Calibri" pitchFamily="34" charset="-122"/>
+                <a:cs typeface="Calibri" pitchFamily="34" charset="-120"/>
+              </a:rPr>
+              <a:t>~800 MHz / ~200 FPS</a:t>
+            </a:r>
+            <a:pPr indent="0" marL="0">
+              <a:lnSpc>
+                <a:spcPct val="115000"/>
+              </a:lnSpc>
+              <a:buNone/>
+            </a:pPr>
+            <a:r>
+              <a:rPr lang="en-US" sz="1400" dirty="0">
+                <a:solidFill>
+                  <a:srgbClr val="9FB0D0"/>
+                </a:solidFill>
+                <a:latin typeface="Calibri" pitchFamily="34" charset="0"/>
+                <a:ea typeface="Calibri" pitchFamily="34" charset="-122"/>
+                <a:cs typeface="Calibri" pitchFamily="34" charset="-120"/>
+              </a:rPr>
+              <a:t> at constant 255 FPS/W</a:t>
+            </a:r>
+            <a:endParaRPr lang="en-US" sz="1400" dirty="0"/>
           </a:p>
         </p:txBody>
       </p:sp>

</xml_diff>

<commit_message>
Pitch deck: replace stretched 4-panel cost image with clean native-style TCO bar chart
- Cost slide (6) now shows a single dark-themed horizontal 3-yr fleet TCO chart
- Matches deck styling: transparent bg over the card, Consolas font, amber diamond
  eyebrow + blue title, Silicon YOLO highlighted in amber vs competitors in blue
- Correct aspect ratio (no stretching); real numbers from COST_COMPARISON.md
  (Silicon YOLO $2.78M vs RTX 4060 $75.3M / 27x, Jetson $30.8M / 11x, etc.)
</commit_message>
<xml_diff>
--- a/docs/SiliconYOLO_pitch.pptx
+++ b/docs/SiliconYOLO_pitch.pptx
@@ -15800,16 +15800,17 @@
       </p:sp>
       <p:pic>
         <p:nvPicPr>
-          <p:cNvPr id="60" name="Image 0" descr="C:\Users\light\AppData\Roaming\simular-unified-ui\SimularFiles\artifacts\pptx_build\costchart.png">    </p:cNvPr>
+          <p:cNvPr id="60" name="Picture 59" descr="tco_chart.png"/>
           <p:cNvPicPr>
             <a:picLocks noChangeAspect="1"/>
           </p:cNvPicPr>
           <p:nvPr/>
         </p:nvPicPr>
         <p:blipFill>
-          <a:blip r:embed="rId1"/>
-          <a:srcRect l="0" r="0" t="0" b="0"/>
-          <a:stretch/>
+          <a:blip r:embed="rId4"/>
+          <a:stretch>
+            <a:fillRect/>
+          </a:stretch>
         </p:blipFill>
         <p:spPr>
           <a:xfrm>

</xml_diff>